<commit_message>
PPT and video created
</commit_message>
<xml_diff>
--- a/Review2_Submission/R2_BATCH_MCA_9224116032_Deepak_Kumar.pptx
+++ b/Review2_Submission/R2_BATCH_MCA_9224116032_Deepak_Kumar.pptx
@@ -2008,14 +2008,11 @@
           <a:p>
             <a:pPr algn="ctr"/>
             <a:r>
-              <a:rPr lang="en-IN" sz="2600" b="1">
-                <a:latin typeface="Times New Roman" panose="02020603050405020304" pitchFamily="18" charset="0"/>
-              </a:rPr>
-              <a:t>Jan -2024</a:t>
-            </a:r>
-            <a:endParaRPr lang="en-IN" sz="2600" b="1" dirty="0">
-              <a:latin typeface="Times New Roman" panose="02020603050405020304" pitchFamily="18" charset="0"/>
-            </a:endParaRPr>
+              <a:rPr lang="en-IN" sz="2600" b="1" dirty="0">
+                <a:latin typeface="Times New Roman" panose="02020603050405020304" pitchFamily="18" charset="0"/>
+              </a:rPr>
+              <a:t>July -2024</a:t>
+            </a:r>
           </a:p>
         </p:txBody>
       </p:sp>
@@ -5532,11 +5529,18 @@
               </a:lnSpc>
             </a:pPr>
             <a:r>
-              <a:rPr lang="en-US" sz="1300">
+              <a:rPr lang="en-US" sz="1300" dirty="0" err="1">
                 <a:latin typeface="Times New Roman" panose="02020603050405020304" pitchFamily="18" charset="0"/>
                 <a:cs typeface="Times New Roman" panose="02020603050405020304" pitchFamily="18" charset="0"/>
               </a:rPr>
-              <a:t>MaatriCare provides an authenticated workspace for pregnancy records, appointments, daily care, private journaling, educational resources, user-controlled reports, and reminders. The system focuses on organization and communication support.</a:t>
+              <a:t>MaatriCare</a:t>
+            </a:r>
+            <a:r>
+              <a:rPr lang="en-US" sz="1300" dirty="0">
+                <a:latin typeface="Times New Roman" panose="02020603050405020304" pitchFamily="18" charset="0"/>
+                <a:cs typeface="Times New Roman" panose="02020603050405020304" pitchFamily="18" charset="0"/>
+              </a:rPr>
+              <a:t> provides an authenticated workspace for pregnancy records, appointments, daily care, private journaling, educational resources, user-controlled reports, and reminders. The system focuses on organization and communication support.</a:t>
             </a:r>
           </a:p>
           <a:p>
@@ -5545,7 +5549,7 @@
                 <a:spcPct val="150000"/>
               </a:lnSpc>
             </a:pPr>
-            <a:endParaRPr lang="en-US" sz="1300">
+            <a:endParaRPr lang="en-US" sz="1300" dirty="0">
               <a:latin typeface="Times New Roman" panose="02020603050405020304" pitchFamily="18" charset="0"/>
               <a:cs typeface="Times New Roman" panose="02020603050405020304" pitchFamily="18" charset="0"/>
             </a:endParaRPr>
@@ -5557,7 +5561,7 @@
               </a:lnSpc>
             </a:pPr>
             <a:r>
-              <a:rPr lang="en-US" sz="1300">
+              <a:rPr lang="en-US" sz="1300" dirty="0">
                 <a:latin typeface="Times New Roman" panose="02020603050405020304" pitchFamily="18" charset="0"/>
                 <a:cs typeface="Times New Roman" panose="02020603050405020304" pitchFamily="18" charset="0"/>
               </a:rPr>
@@ -5571,7 +5575,7 @@
               </a:lnSpc>
             </a:pPr>
             <a:r>
-              <a:rPr lang="en-US" sz="1300">
+              <a:rPr lang="en-US" sz="1300" dirty="0">
                 <a:latin typeface="Times New Roman" panose="02020603050405020304" pitchFamily="18" charset="0"/>
                 <a:cs typeface="Times New Roman" panose="02020603050405020304" pitchFamily="18" charset="0"/>
               </a:rPr>
@@ -5585,7 +5589,7 @@
               </a:lnSpc>
             </a:pPr>
             <a:r>
-              <a:rPr lang="en-US" sz="1300">
+              <a:rPr lang="en-US" sz="1300" dirty="0">
                 <a:latin typeface="Times New Roman" panose="02020603050405020304" pitchFamily="18" charset="0"/>
                 <a:cs typeface="Times New Roman" panose="02020603050405020304" pitchFamily="18" charset="0"/>
               </a:rPr>
@@ -5599,7 +5603,7 @@
               </a:lnSpc>
             </a:pPr>
             <a:r>
-              <a:rPr lang="en-US" sz="1300">
+              <a:rPr lang="en-US" sz="1300" dirty="0">
                 <a:latin typeface="Times New Roman" panose="02020603050405020304" pitchFamily="18" charset="0"/>
                 <a:cs typeface="Times New Roman" panose="02020603050405020304" pitchFamily="18" charset="0"/>
               </a:rPr>
@@ -5613,7 +5617,7 @@
               </a:lnSpc>
             </a:pPr>
             <a:r>
-              <a:rPr lang="en-US" sz="1300">
+              <a:rPr lang="en-US" sz="1300" dirty="0">
                 <a:latin typeface="Times New Roman" panose="02020603050405020304" pitchFamily="18" charset="0"/>
                 <a:cs typeface="Times New Roman" panose="02020603050405020304" pitchFamily="18" charset="0"/>
               </a:rPr>
@@ -5627,7 +5631,7 @@
               </a:lnSpc>
             </a:pPr>
             <a:r>
-              <a:rPr lang="en-US" sz="1300">
+              <a:rPr lang="en-US" sz="1300" dirty="0">
                 <a:latin typeface="Times New Roman" panose="02020603050405020304" pitchFamily="18" charset="0"/>
                 <a:cs typeface="Times New Roman" panose="02020603050405020304" pitchFamily="18" charset="0"/>
               </a:rPr>

</xml_diff>